<commit_message>
Update Rabby final slide— 2026-06-08 16:25
</commit_message>
<xml_diff>
--- a/final_slide/wallet_demo/ChainShield_Presentation.pptx
+++ b/final_slide/wallet_demo/ChainShield_Presentation.pptx
@@ -2094,6 +2094,66 @@
               <a:buNone/>
             </a:pPr>
             <a:endParaRPr lang="en-US" sz="900" dirty="0"/>
+          </a:p>
+        </p:txBody>
+      </p:sp>
+      <p:pic>
+        <p:nvPicPr>
+          <p:cNvPr id="30" name="QR Code" descr="Scan to visit demo"/>
+          <p:cNvPicPr>
+            <a:picLocks noChangeAspect="1"/>
+          </p:cNvPicPr>
+          <p:nvPr/>
+        </p:nvPicPr>
+        <p:blipFill>
+          <a:blip r:embed="rId4"/>
+          <a:stretch>
+            <a:fillRect/>
+          </a:stretch>
+        </p:blipFill>
+        <p:spPr>
+          <a:xfrm>
+            <a:off x="300000" y="3700000"/>
+            <a:ext cx="1200000" cy="1200000"/>
+          </a:xfrm>
+          <a:prstGeom prst="rect">
+            <a:avLst/>
+          </a:prstGeom>
+        </p:spPr>
+      </p:pic>
+      <p:sp>
+        <p:nvSpPr>
+          <p:cNvPr id="31" name="QR Label"/>
+          <p:cNvSpPr/>
+          <p:nvPr/>
+        </p:nvSpPr>
+        <p:spPr>
+          <a:xfrm>
+            <a:off x="200000" y="4950000"/>
+            <a:ext cx="1400000" cy="150000"/>
+          </a:xfrm>
+          <a:prstGeom prst="rect">
+            <a:avLst/>
+          </a:prstGeom>
+          <a:noFill/>
+          <a:ln/>
+        </p:spPr>
+        <p:txBody>
+          <a:bodyPr wrap="square" rtlCol="0" anchor="ctr"/>
+          <a:lstStyle/>
+          <a:p>
+            <a:pPr marL="0" indent="0" algn="ctr">
+              <a:buNone/>
+            </a:pPr>
+            <a:r>
+              <a:rPr lang="en-US" sz="700" dirty="0">
+                <a:solidFill>
+                  <a:srgbClr val="8B9BB4"/>
+                </a:solidFill>
+                <a:latin typeface="Trebuchet MS" pitchFamily="34" charset="0"/>
+              </a:rPr>
+              <a:t>Scan to view live demo</a:t>
+            </a:r>
           </a:p>
         </p:txBody>
       </p:sp>

</xml_diff>